<commit_message>
chore(preview): comparatif AAPL_vs_MSFT outputs
</commit_message>
<xml_diff>
--- a/preview/AAPL_vs_MSFT/AAPL_vs_MSFT_comparison.pptx
+++ b/preview/AAPL_vs_MSFT/AAPL_vs_MSFT_comparison.pptx
@@ -3606,7 +3606,7 @@
                 </a:solidFill>
                 <a:latin typeface="Calibri"/>
               </a:rPr>
-              <a:t>● HOLD  ·  Cible : 587 $  ·  Upside : +58,4 %</a:t>
+              <a:t>● HOLD  ·  Cible : 587 $  ·  Upside : +58,6 %</a:t>
             </a:r>
           </a:p>
         </p:txBody>
@@ -3789,7 +3789,7 @@
                 </a:solidFill>
                 <a:latin typeface="Calibri"/>
               </a:rPr>
-              <a:t>261,5 $</a:t>
+              <a:t>261,7 $</a:t>
             </a:r>
           </a:p>
         </p:txBody>
@@ -3859,7 +3859,7 @@
                 </a:solidFill>
                 <a:latin typeface="Calibri"/>
               </a:rPr>
-              <a:t>3 839,4 Mds$</a:t>
+              <a:t>3 841,8 Mds$</a:t>
             </a:r>
           </a:p>
         </p:txBody>
@@ -4112,7 +4112,7 @@
                 </a:solidFill>
                 <a:latin typeface="Calibri"/>
               </a:rPr>
-              <a:t>370,9 $</a:t>
+              <a:t>370,4 $</a:t>
             </a:r>
           </a:p>
         </p:txBody>
@@ -4182,7 +4182,7 @@
                 </a:solidFill>
                 <a:latin typeface="Calibri"/>
               </a:rPr>
-              <a:t>2 754,0 Mds$</a:t>
+              <a:t>2 750,5 Mds$</a:t>
             </a:r>
           </a:p>
         </p:txBody>
@@ -5580,7 +5580,7 @@
                 </a:solidFill>
                 <a:latin typeface="Calibri"/>
               </a:rPr>
-              <a:t>Commentaire de valorisation (AAPL vs MSFT) Quoi : AAPL affiche des multiples élevés (PE 34.3x, PB 52.1x) vs MSFT (PE 27.0x, PB 8.0x), reflétant une prime de croissance et de rentabilité. Pourquoi : MSFT surpasse AAPL en marge EBITDA (56.9% vs 34.8%), ROIC (30.1% vs 84.4%) et croissance du CA (12.4% vs 1.8%), justifiant une décote. AAPL bénéficie d’une trésorerie nette élevée et d’une rentabilité exceptionnelle, mais son levier opérationnel est moins favorable. Implications investisseur : MSFT offre un meilleur rapport risque/rendement avec une prime de croissance sous-évaluée. AAPL mérite sa prime pour sa résilience, mais son upside relatif est limité par des</a:t>
+              <a:t>AAPL vs MSFT : Décote justifiée mais upside limité Quoi : AAPL affiche des multiples élevés (PE 34.3x, PB 52.1x) vs MSFT (PE 27.0x, PB 8.0x), malgré une rentabilité supérieure (ROIC 84.4% vs 30.1%). Pourquoi : La décote de MSFT s’explique par des marges EBITDA supérieures (56.9% vs 34.8%), une croissance organique plus forte (CAGR 12.4% vs 1.8%) et un bilan plus solide (ND/EBITDA 0.1x vs 0.4x). Les scores FinSight (58 vs 44) et Piotroski (5 vs 7) renforcent cette analyse. Implications : AAPL offre un upside limité (FCF yield 2.9% vs 2.6%), tandis que MSFT présente un meilleur profil risque/rendement. Recommandation : Surpondérer MSFT.</a:t>
             </a:r>
           </a:p>
         </p:txBody>
@@ -5857,7 +5857,7 @@
                           </a:solidFill>
                           <a:latin typeface="Calibri"/>
                         </a:rPr>
-                        <a:t>17,3x</a:t>
+                        <a:t>17,2x</a:t>
                       </a:r>
                     </a:p>
                   </a:txBody>
@@ -7131,7 +7131,7 @@
                 </a:solidFill>
                 <a:latin typeface="Calibri"/>
               </a:rPr>
-              <a:t>MSFT offre le meilleur upside DCF base : +58% vs cours actuel</a:t>
+              <a:t>MSFT offre le meilleur upside DCF base : +59% vs cours actuel</a:t>
             </a:r>
           </a:p>
         </p:txBody>
@@ -7365,7 +7365,7 @@
                 </a:solidFill>
                 <a:latin typeface="Calibri"/>
               </a:rPr>
-              <a:t>261,5 $</a:t>
+              <a:t>261,7 $</a:t>
             </a:r>
           </a:p>
         </p:txBody>
@@ -7930,7 +7930,7 @@
                 </a:solidFill>
                 <a:latin typeface="Calibri"/>
               </a:rPr>
-              <a:t>11,7 %</a:t>
+              <a:t>11,6 %</a:t>
             </a:r>
           </a:p>
         </p:txBody>
@@ -8729,7 +8729,7 @@
                 </a:solidFill>
                 <a:latin typeface="Calibri"/>
               </a:rPr>
-              <a:t>370,9 $</a:t>
+              <a:t>370,4 $</a:t>
             </a:r>
           </a:p>
         </p:txBody>
@@ -9181,7 +9181,7 @@
                 </a:solidFill>
                 <a:latin typeface="Calibri"/>
               </a:rPr>
-              <a:t>+58,4 %</a:t>
+              <a:t>+58,6 %</a:t>
             </a:r>
           </a:p>
         </p:txBody>
@@ -9746,7 +9746,7 @@
                 </a:solidFill>
                 <a:latin typeface="Calibri"/>
               </a:rPr>
-              <a:t>339 $</a:t>
+              <a:t>338 $</a:t>
             </a:r>
           </a:p>
         </p:txBody>
@@ -9859,7 +9859,7 @@
                 </a:solidFill>
                 <a:latin typeface="Calibri"/>
               </a:rPr>
-              <a:t>463 $</a:t>
+              <a:t>462 $</a:t>
             </a:r>
           </a:p>
         </p:txBody>
@@ -11133,7 +11133,7 @@
                 </a:solidFill>
                 <a:latin typeface="Calibri"/>
               </a:rPr>
-              <a:t>Le modele DCF Bear/Base/Bull et la simulation GBM Monte Carlo donnent deux lectures complementaires de la valorisation. AAPL affiche un upside base de +13% vs +58% pour MSFT. Le football field ci-dessous visualise les fourchettes intrinseques de chaque titre : plus la bande est etendue, plus l'incertitude sur la valeur est elevee. La ligne pointillee indique le cours actuel ; si elle se situe sous la barre Base, le titre est dans une zone d'achat theorique. A croiser avec les hypotheses WACC/TGR (sensibilite des flux futurs) et la credibilite du scenario macro.</a:t>
+              <a:t>Le modele DCF Bear/Base/Bull et la simulation GBM Monte Carlo donnent deux lectures complementaires de la valorisation. AAPL affiche un upside base de +13% vs +59% pour MSFT. Le football field ci-dessous visualise les fourchettes intrinseques de chaque titre : plus la bande est etendue, plus l'incertitude sur la valeur est elevee. La ligne pointillee indique le cours actuel ; si elle se situe sous la barre Base, le titre est dans une zone d'achat theorique. A croiser avec les hypotheses WACC/TGR (sensibilite des flux futurs) et la credibilite du scenario macro.</a:t>
             </a:r>
           </a:p>
         </p:txBody>
@@ -11269,7 +11269,7 @@
                           </a:solidFill>
                           <a:latin typeface="Calibri"/>
                         </a:rPr>
-                        <a:t>218 $  (-16,7 %)</a:t>
+                        <a:t>218 $  (-16,8 %)</a:t>
                       </a:r>
                     </a:p>
                   </a:txBody>
@@ -11292,7 +11292,7 @@
                           </a:solidFill>
                           <a:latin typeface="Calibri"/>
                         </a:rPr>
-                        <a:t>247 $  (-33,3 %)</a:t>
+                        <a:t>247 $  (-33,4 %)</a:t>
                       </a:r>
                     </a:p>
                   </a:txBody>
@@ -11363,7 +11363,7 @@
                           </a:solidFill>
                           <a:latin typeface="Calibri"/>
                         </a:rPr>
-                        <a:t>339 $  (-8,7 %)</a:t>
+                        <a:t>338 $  (-8,7 %)</a:t>
                       </a:r>
                     </a:p>
                   </a:txBody>
@@ -11411,7 +11411,7 @@
                           </a:solidFill>
                           <a:latin typeface="Calibri"/>
                         </a:rPr>
-                        <a:t>453 $  (+73,2 %)</a:t>
+                        <a:t>453 $  (+73,1 %)</a:t>
                       </a:r>
                     </a:p>
                   </a:txBody>
@@ -11434,7 +11434,7 @@
                           </a:solidFill>
                           <a:latin typeface="Calibri"/>
                         </a:rPr>
-                        <a:t>463 $  (+24,8 %)</a:t>
+                        <a:t>462 $  (+24,8 %)</a:t>
                       </a:r>
                     </a:p>
                   </a:txBody>
@@ -11553,7 +11553,7 @@
                           </a:solidFill>
                           <a:latin typeface="Calibri"/>
                         </a:rPr>
-                        <a:t>261,52 $</a:t>
+                        <a:t>261,68 $</a:t>
                       </a:r>
                     </a:p>
                   </a:txBody>
@@ -11576,7 +11576,7 @@
                           </a:solidFill>
                           <a:latin typeface="Calibri"/>
                         </a:rPr>
-                        <a:t>370,88 $</a:t>
+                        <a:t>370,40 $</a:t>
                       </a:r>
                     </a:p>
                   </a:txBody>
@@ -12718,7 +12718,7 @@
         <p:spPr>
           <a:xfrm>
             <a:off x="367200" y="928800"/>
-            <a:ext cx="8413200" cy="720000"/>
+            <a:ext cx="8413200" cy="756000"/>
           </a:xfrm>
           <a:prstGeom prst="rect">
             <a:avLst/>
@@ -12761,7 +12761,7 @@
         <p:spPr>
           <a:xfrm>
             <a:off x="367200" y="928800"/>
-            <a:ext cx="46800" cy="720000"/>
+            <a:ext cx="46800" cy="756000"/>
           </a:xfrm>
           <a:prstGeom prst="rect">
             <a:avLst/>
@@ -12804,7 +12804,7 @@
         <p:spPr>
           <a:xfrm>
             <a:off x="503999" y="964800"/>
-            <a:ext cx="8208000" cy="648000"/>
+            <a:ext cx="8136000" cy="684000"/>
           </a:xfrm>
           <a:prstGeom prst="rect">
             <a:avLst/>
@@ -12819,16 +12819,13 @@
           <a:p>
             <a:pPr algn="l"/>
             <a:r>
-              <a:rPr sz="900" b="0" i="0">
+              <a:rPr sz="850" b="0" i="0">
                 <a:solidFill>
                   <a:srgbClr val="1B3A6B"/>
                 </a:solidFill>
                 <a:latin typeface="Calibri"/>
               </a:rPr>
-              <a:t>Analyse comparative AAPL vs MSFT – Solidité bilancielle
-Quoi : AAPL affiche un levier financier modéré (ND/EBITDA=0.4) mais un Piotroski élevé (7/9), signe d’une santé financière robuste. MSFT, avec un levier quasi nul (0.1) et un Piotroski de 5/9, est encore plus conservateur.
-Pourquoi : AAPL combine croissance organique (CAGR 1.8%) et marge EBITDA élevée (34.8%), mais son ROE (151.9%) reflète une trésorerie excédentaire. MSFT, avec un ROIC (30.1%) et des marges (56.9%) supérieurs, optimise mieux son capital.
-Implications : MSFT offre un profil moins risqué (levier, Piotroski)</a:t>
+              <a:t>Solidité bilancielle : AAPL &gt; MSFT Pourquoi : AAPL affiche un levier (ND/EBITDA=0.4) plus élevé que MSFT (0.1), mais avec un Piotroski de 7 (vs 5) et un FinSight de 44 (vs 58), reflétant une meilleure qualité financière. Les marges EBITDA (34.8% vs 56.9%) et ROIC (84.4% vs 30.1%) soulignent une rentabilité supérieure pour AAPL, compensant son</a:t>
             </a:r>
           </a:p>
         </p:txBody>
@@ -15108,7 +15105,7 @@
                           </a:solidFill>
                           <a:latin typeface="Calibri"/>
                         </a:rPr>
-                        <a:t>+3,1 %</a:t>
+                        <a:t>+2,8 %</a:t>
                       </a:r>
                     </a:p>
                   </a:txBody>
@@ -15131,7 +15128,7 @@
                           </a:solidFill>
                           <a:latin typeface="Calibri"/>
                         </a:rPr>
-                        <a:t>+0,2 %</a:t>
+                        <a:t>+0,1 %</a:t>
                       </a:r>
                     </a:p>
                   </a:txBody>
@@ -15179,7 +15176,7 @@
                           </a:solidFill>
                           <a:latin typeface="Calibri"/>
                         </a:rPr>
-                        <a:t>+0,9 %</a:t>
+                        <a:t>+0,6 %</a:t>
                       </a:r>
                     </a:p>
                   </a:txBody>
@@ -15202,7 +15199,7 @@
                           </a:solidFill>
                           <a:latin typeface="Calibri"/>
                         </a:rPr>
-                        <a:t>-13,6 %</a:t>
+                        <a:t>-13,7 %</a:t>
                       </a:r>
                     </a:p>
                   </a:txBody>
@@ -15250,7 +15247,7 @@
                           </a:solidFill>
                           <a:latin typeface="Calibri"/>
                         </a:rPr>
-                        <a:t>+30,8 %</a:t>
+                        <a:t>+30,4 %</a:t>
                       </a:r>
                     </a:p>
                   </a:txBody>
@@ -15273,7 +15270,7 @@
                           </a:solidFill>
                           <a:latin typeface="Calibri"/>
                         </a:rPr>
-                        <a:t>-18,8 %</a:t>
+                        <a:t>-18,9 %</a:t>
                       </a:r>
                     </a:p>
                   </a:txBody>
@@ -16120,7 +16117,7 @@
                 </a:solidFill>
                 <a:latin typeface="Calibri"/>
               </a:rPr>
-              <a:t>Profil de risque : MSFT presente une sensibilite marche moindre (beta 1.11), adapte aux portefeuilles prudents. Sur le momentum 3 mois, AAPL prend la tete (+0.9% vs -13.6%). La volatilite annualisee (24% vs 24%) calibre le dimensionnement de position : une volatilite plus elevee impose une ponderation reduite pour maintenir un budget risque equivalent.</a:t>
+              <a:t>Profil de risque : MSFT presente une sensibilite marche moindre (beta 1.11), adapte aux portefeuilles prudents. Sur le momentum 3 mois, AAPL prend la tete (+0.6% vs -13.7%). La volatilite annualisee (24% vs 24%) calibre le dimensionnement de position : une volatilite plus elevee impose une ponderation reduite pour maintenir un budget risque equivalent.</a:t>
             </a:r>
           </a:p>
         </p:txBody>
@@ -19580,7 +19577,7 @@
                 </a:solidFill>
                 <a:latin typeface="Calibri"/>
               </a:rPr>
-              <a:t>Cours : 261,5 $  ·  52W : 186,1 - 288,6 $</a:t>
+              <a:t>Cours : 261,7 $  ·  52W : 186,1 - 288,6 $</a:t>
             </a:r>
           </a:p>
         </p:txBody>
@@ -19615,7 +19612,7 @@
                 </a:solidFill>
                 <a:latin typeface="Calibri"/>
               </a:rPr>
-              <a:t>Perf 1Y : +30,8 %  ·  Div. : 0,4 %</a:t>
+              <a:t>Perf 1Y : +30,4 %  ·  Div. : 0,4 %</a:t>
             </a:r>
           </a:p>
         </p:txBody>
@@ -19736,7 +19733,7 @@
                 </a:solidFill>
                 <a:latin typeface="Calibri"/>
               </a:rPr>
-              <a:t>Cours : 370,9 $  ·  52W : 355,7 - 555,5 $</a:t>
+              <a:t>Cours : 370,4 $  ·  52W : 355,7 - 555,5 $</a:t>
             </a:r>
           </a:p>
         </p:txBody>
@@ -19771,7 +19768,7 @@
                 </a:solidFill>
                 <a:latin typeface="Calibri"/>
               </a:rPr>
-              <a:t>Perf 1Y : -18,8 %  ·  Div. : 0,9 %</a:t>
+              <a:t>Perf 1Y : -18,9 %  ·  Div. : 0,9 %</a:t>
             </a:r>
           </a:p>
         </p:txBody>
@@ -19970,8 +19967,8 @@
                 </a:solidFill>
                 <a:latin typeface="Calibri"/>
               </a:rPr>
-              <a:t>Thèse bull (AAPL) :
-Apple combine une marge EBITDA élevée (34,8%) et une rentabilité exceptionnelle (ROIC 84,4%) grâce à son écosystème intégré et sa forte récurrence des revenus (services). La valorisation reste justifiée par la croissance des services (+15% YoY) et l’innovation hardware (IA, Vision Pro). Les fondamentaux solides et la trésore</a:t>
+              <a:t>Thèse bull (AAPL):
+Apple capitalise sur son écosystème intégré (iPhone, services, wearables) et sa marge brute élevée (40%+), avec une croissance des services (+14% YoY) et un ROIC exceptionnel (84%). La valorisation reste justifiée par la résilience de la demande premium et l'innovation (IA, AR/VR).</a:t>
             </a:r>
           </a:p>
         </p:txBody>
@@ -20170,8 +20167,7 @@
                 </a:solidFill>
                 <a:latin typeface="Calibri"/>
               </a:rPr>
-              <a:t>MSFT – Thèse bull
-Croissance soutenue par l’IA (Azure, Copilot) et la résilience des abonnements cloud (Office 365, LinkedIn). Marges EBITDA élevées (56,9 %) et faible levier (ND/EBITDA=0,1) offrent une visibilité. Valorisation attractive vs historique (PE=27x vs moyenne 30x).</a:t>
+              <a:t>Thèse bull (MSFT) : Croissance soutenue des revenus (+12,4% CAGR 3 ans) portée par l’IA (Azure, Copilot) et les abonnements (Office 365, LinkedIn). Marges EBITDA élevées (56,9%) et faible levier (ND/EBITDA=0,1) offrent une visibilité opérationnelle et une capacité d’investissement accrue. Valorisation attractive vs AAPL (EV/EBITDA 17,2x vs 27,0</a:t>
             </a:r>
           </a:p>
         </p:txBody>
@@ -20370,8 +20366,8 @@
                 </a:solidFill>
                 <a:latin typeface="Calibri"/>
               </a:rPr>
-              <a:t>Thèse bear (AAPL) :
-La croissance des revenus ralentit (CAGR 3 ans : 1,8%) et la valorisation est élevée (PE 34,3x, PB 52,1x). La dépendance aux iPhones (50% des revenus) expose à un cycle de consommation affaibli. Les marges des services pourraient se compr</a:t>
+              <a:t>Thèse bear (AAPL):
+La dépendance à l'iPhone (50% des revenus) et la saturation du marché premium limitent la croissance organique. Les marges des services sont sous pression (coûts de contenu, régulation), et la valorisation élevée (PE=34x) n'est pas compensée par un levier financier modéré (ND/EBITDA=0.4).</a:t>
             </a:r>
           </a:p>
         </p:txBody>
@@ -20570,8 +20566,8 @@
                 </a:solidFill>
                 <a:latin typeface="Calibri"/>
               </a:rPr>
-              <a:t>MSFT – Thèse bear
-Ralentissement de la demande cloud (concurrence AWS/GCP) et pression sur les marges. Risque de saturation du marché des PC (dépendance au hardware). Valorisation premium justifiée seulement si croissance IA se matérialise durablement.</a:t>
+              <a:t>
+Thèse bear (MSFT) : Concurrence accrue dans le cloud (AWS, Google Cloud) et pression sur les marges de l’IA malgré les investissements massifs. Risque de ralentissement des dépenses IT des entreprises en cas de récession. Valorisation élevée en termes de PB (8,0x) malgré un ROE solide</a:t>
             </a:r>
           </a:p>
         </p:txBody>
@@ -21533,7 +21529,7 @@
                 </a:solidFill>
                 <a:latin typeface="Calibri"/>
               </a:rPr>
-              <a:t>Executive Summary comparatif (AAPL vs MSFT) Quoi : MSFT affiche une valorisation plus attractive (PE 27x vs 34x, EV/EBITDA 17x vs 27x) avec des marges EBITDA supérieures (57% vs 35%) et une croissance organique plus élevée (CAGR 12% vs 2%). Pourquoi : MSFT combine rentabilité supérieure (ROIC 30% vs 84% mais plus durable), moindre levier (ND/EBITDA 0.1 vs 0.4) et meilleure qualité financière (FinSight 58 vs 44). Implications investisseur : MSFT offre un meilleur rapport qualité/valorisation, justifié par une exécution opérationnelle supérieure et une croissance structurelle (cloud, IA). AAPL reste premium mais moins attractif en termes de</a:t>
+              <a:t>Executive Summary : AAPL vs MSFT Quoi : Comparaison des valorisations et fondamentaux entre Apple (AAPL) et Microsoft (MSFT). Pourquoi : MSFT offre un meilleur rapport qualité/valorisation grâce à des multiples plus attractifs (PE 27x vs 34x, EV/EBITDA 17x vs 27x) et une profitabilité supérieure (EBITDA margin 57% vs 35%, ROIC 30% vs 84%). Implications : MSFT présente une croissance plus robuste (CAGR 12% vs 2%) et un levier financier plus sain (ND/EBITDA 0.1 vs 0.4), justifiant sa préférence pour les investisseurs.</a:t>
             </a:r>
           </a:p>
         </p:txBody>
@@ -22189,7 +22185,7 @@
                           </a:solidFill>
                           <a:latin typeface="Calibri"/>
                         </a:rPr>
-                        <a:t>▲ 17,3x</a:t>
+                        <a:t>▲ 17,2x</a:t>
                       </a:r>
                     </a:p>
                   </a:txBody>
@@ -23025,7 +23021,7 @@
                 </a:solidFill>
                 <a:latin typeface="Calibri"/>
               </a:rPr>
-              <a:t>AAPL surperforme sur 12 mois (ecart de 50 pts)</a:t>
+              <a:t>AAPL surperforme sur 12 mois (ecart de 49 pts)</a:t>
             </a:r>
           </a:p>
         </p:txBody>
@@ -23240,7 +23236,7 @@
                 </a:solidFill>
                 <a:latin typeface="Calibri"/>
               </a:rPr>
-              <a:t>261,5 $</a:t>
+              <a:t>261,7 $</a:t>
             </a:r>
           </a:p>
         </p:txBody>
@@ -23380,7 +23376,7 @@
                 </a:solidFill>
                 <a:latin typeface="Calibri"/>
               </a:rPr>
-              <a:t>+3,1 %</a:t>
+              <a:t>+2,8 %</a:t>
             </a:r>
           </a:p>
         </p:txBody>
@@ -23520,7 +23516,7 @@
                 </a:solidFill>
                 <a:latin typeface="Calibri"/>
               </a:rPr>
-              <a:t>+0,9 %</a:t>
+              <a:t>+0,6 %</a:t>
             </a:r>
           </a:p>
         </p:txBody>
@@ -23660,7 +23656,7 @@
                 </a:solidFill>
                 <a:latin typeface="Calibri"/>
               </a:rPr>
-              <a:t>+30,8 %</a:t>
+              <a:t>+30,4 %</a:t>
             </a:r>
           </a:p>
         </p:txBody>
@@ -23921,7 +23917,7 @@
                 </a:solidFill>
                 <a:latin typeface="Calibri"/>
               </a:rPr>
-              <a:t>370,9 $</a:t>
+              <a:t>370,4 $</a:t>
             </a:r>
           </a:p>
         </p:txBody>
@@ -24061,7 +24057,7 @@
                 </a:solidFill>
                 <a:latin typeface="Calibri"/>
               </a:rPr>
-              <a:t>+0,2 %</a:t>
+              <a:t>+0,1 %</a:t>
             </a:r>
           </a:p>
         </p:txBody>
@@ -24201,7 +24197,7 @@
                 </a:solidFill>
                 <a:latin typeface="Calibri"/>
               </a:rPr>
-              <a:t>-13,6 %</a:t>
+              <a:t>-13,7 %</a:t>
             </a:r>
           </a:p>
         </p:txBody>
@@ -24341,7 +24337,7 @@
                 </a:solidFill>
                 <a:latin typeface="Calibri"/>
               </a:rPr>
-              <a:t>-18,8 %</a:t>
+              <a:t>-18,9 %</a:t>
             </a:r>
           </a:p>
         </p:txBody>
@@ -24567,7 +24563,7 @@
                 </a:solidFill>
                 <a:latin typeface="Calibri"/>
               </a:rPr>
-              <a:t>Contexte macro : Hausse des taux directeurs (Fed +500bps depuis 2022) pénalise les valorisations des growth stocks. Cycle économique en ralentissement (PMI manufacturier &lt;50 aux US/EU) et rotation sectorielle vers les valeurs défensives. L’IA générative a soutenu les techs en 2023, mais la demande en cloud et devices montre des signes de fatigue. Événements clés : - AAPL : +30.8% grâce à l’iPhone 15 (lancement septembre 2023), services récurrents (abonnements) et rachat d’actions (75Md$ annoncé en mai 2023). Guidance prudente sur la demande en Chine. -</a:t>
+              <a:t>Contexte macro : La divergence s’explique par un environnement de hausse des taux (Fed +525bps depuis 2022) favorisant les valeurs défensives (AAPL) et pénalisant les growth (MSFT), ainsi que par une rotation sectorielle vers la tech hardware (soutenue par l’IA et les données) au détriment des logiciels (concurrence accrue, pression sur les marges). Événements clés : - AAPL : +30.4% porté par des résultats solides (Q4’23 : +8% CA, iPhone résilient) et une guidance optimiste (croissance services +10% en 2024), malgré des tensions géopolitiques</a:t>
             </a:r>
           </a:p>
         </p:txBody>
@@ -25755,7 +25751,7 @@
                 </a:solidFill>
                 <a:latin typeface="Calibri"/>
               </a:rPr>
-              <a:t>Choix : MSFT. Pourquoi : 1. Valorisation relative : MSFT affiche un PE de 27x vs 34.3x pour AAPL, avec un EV/EBITDA de 17.3x (vs 27x), suggérant une décote de 36% sur ce multiple clé. 2. Profitabilité supérieure : EBITDA margin à 56.9% (vs 34.8%) et ROIC de 30.1% (vs 84.4%) reflètent une efficacité opérationnelle supérieure. 3. Croissance structurelle : CAGR revenus 3 ans à 12.4% (vs 1.8%) porté par l’IA (Azure, Copilot) et l’adoption cloud. Risque principal : Dépendance aux dépenses IT des entreprises (cycle économique) et pression réglementaire sur l’IA (RGPD,</a:t>
+              <a:t>Choix : MSFT. Pourquoi : MSFT affiche une valorisation plus attractive (PE 27.0x vs 34.3x, EV/EBITDA 17.2x vs 27.0x) malgré une croissance supérieure (Rev CAGR 3y : 12.4% vs 1.8%). Sa profitabilité est exceptionnelle (EBITDA margin 56.9% vs 34.8%, ROIC 30.1% vs 84.4%), avec un bilan solide (ND/EBITDA 0.1 vs 0.4). Les catalyseurs incluent l’adoption croissante de l’IA via Azure et la résilience des revenus récurrents (licences, cloud). Risque principal : Dépendance au segment cloud (Azure) et pression concurrentielle dans l’IA, pouvant impacter les marges à long terme.</a:t>
             </a:r>
           </a:p>
         </p:txBody>
@@ -25911,8 +25907,7 @@
                 </a:solidFill>
                 <a:latin typeface="Calibri"/>
               </a:rPr>
-              <a:t>MSFT – Thèse bull
-Croissance soutenue par l’IA (Azure, Copilot) et la résilience des abonnements cloud (Office 365, LinkedIn). Marges EBITDA élevées (56,9 %) et faible levier (ND/EBITDA=0,1) offrent une visibilité. Valorisation attractive vs historique (PE=27x vs moyenne</a:t>
+              <a:t>Thèse bull (MSFT) : Croissance soutenue des revenus (+12,4% CAGR 3 ans) portée par l’IA (Azure, Copilot) et les abonnements (Office 365, LinkedIn). Marges EBITDA élevées (56,9%) et faible levier (ND/EBITDA=0,1) offrent une visibilité opérationnelle et une capacité</a:t>
             </a:r>
           </a:p>
         </p:txBody>
@@ -26068,8 +26063,8 @@
                 </a:solidFill>
                 <a:latin typeface="Calibri"/>
               </a:rPr>
-              <a:t>MSFT – Thèse bear
-Ralentissement de la demande cloud (concurrence AWS/GCP) et pression sur les marges. Risque de saturation du marché des PC (dépendance au hardware). Valorisation premium justifiée seulement si croissance IA se matérialise durablement.</a:t>
+              <a:t>
+Thèse bear (MSFT) : Concurrence accrue dans le cloud (AWS, Google Cloud) et pression sur les marges de l’IA malgré les investissements massifs. Risque de ralentissement des dépenses IT des entreprises en cas de récession. Valorisation élevée en termes de PB (8,0x) malgré</a:t>
             </a:r>
           </a:p>
         </p:txBody>
@@ -28806,7 +28801,7 @@
                 </a:solidFill>
                 <a:latin typeface="Calibri"/>
               </a:rPr>
-              <a:t>261,5 $</a:t>
+              <a:t>261,7 $</a:t>
             </a:r>
           </a:p>
         </p:txBody>
@@ -29145,7 +29140,7 @@
                 </a:solidFill>
                 <a:latin typeface="Calibri"/>
               </a:rPr>
-              <a:t>3 839,4 Mds $</a:t>
+              <a:t>3 841,8 Mds $</a:t>
             </a:r>
           </a:p>
         </p:txBody>
@@ -29258,7 +29253,7 @@
                 </a:solidFill>
                 <a:latin typeface="Calibri"/>
               </a:rPr>
-              <a:t>3 902,1 Mds $</a:t>
+              <a:t>3 904,5 Mds $</a:t>
             </a:r>
           </a:p>
         </p:txBody>
@@ -29484,7 +29479,7 @@
                 </a:solidFill>
                 <a:latin typeface="Calibri"/>
               </a:rPr>
-              <a:t>+3,1 %</a:t>
+              <a:t>+2,8 %</a:t>
             </a:r>
           </a:p>
         </p:txBody>
@@ -29597,7 +29592,7 @@
                 </a:solidFill>
                 <a:latin typeface="Calibri"/>
               </a:rPr>
-              <a:t>+0,9 %</a:t>
+              <a:t>+0,6 %</a:t>
             </a:r>
           </a:p>
         </p:txBody>
@@ -29710,7 +29705,7 @@
                 </a:solidFill>
                 <a:latin typeface="Calibri"/>
               </a:rPr>
-              <a:t>+30,8 %</a:t>
+              <a:t>+30,4 %</a:t>
             </a:r>
           </a:p>
         </p:txBody>
@@ -30283,7 +30278,7 @@
                 </a:solidFill>
                 <a:latin typeface="Calibri"/>
               </a:rPr>
-              <a:t>370,9 $</a:t>
+              <a:t>370,4 $</a:t>
             </a:r>
           </a:p>
         </p:txBody>
@@ -30622,7 +30617,7 @@
                 </a:solidFill>
                 <a:latin typeface="Calibri"/>
               </a:rPr>
-              <a:t>2 754,0 Mds $</a:t>
+              <a:t>2 750,5 Mds $</a:t>
             </a:r>
           </a:p>
         </p:txBody>
@@ -30735,7 +30730,7 @@
                 </a:solidFill>
                 <a:latin typeface="Calibri"/>
               </a:rPr>
-              <a:t>2 766,9 Mds $</a:t>
+              <a:t>2 763,4 Mds $</a:t>
             </a:r>
           </a:p>
         </p:txBody>
@@ -30961,7 +30956,7 @@
                 </a:solidFill>
                 <a:latin typeface="Calibri"/>
               </a:rPr>
-              <a:t>+0,2 %</a:t>
+              <a:t>+0,1 %</a:t>
             </a:r>
           </a:p>
         </p:txBody>
@@ -31074,7 +31069,7 @@
                 </a:solidFill>
                 <a:latin typeface="Calibri"/>
               </a:rPr>
-              <a:t>-13,6 %</a:t>
+              <a:t>-13,7 %</a:t>
             </a:r>
           </a:p>
         </p:txBody>
@@ -31187,7 +31182,7 @@
                 </a:solidFill>
                 <a:latin typeface="Calibri"/>
               </a:rPr>
-              <a:t>-18,8 %</a:t>
+              <a:t>-18,9 %</a:t>
             </a:r>
           </a:p>
         </p:txBody>
@@ -33181,7 +33176,7 @@
                 </a:solidFill>
                 <a:latin typeface="Calibri"/>
               </a:rPr>
-              <a:t>AAPL vs MSFT : Analyse comparative Quoi : MSFT affiche des marges (EBITDA 56.9% vs 34.8%) et une croissance (CAGR 12.4% vs 1.8%) supérieures à AAPL, malgré des valorisations plus attractives (PE 27x vs 34.3x, EV/EBITDA 17.3x vs 27x). Pourquoi : Modèle SaaS (MSFT) vs hardware (AAPL) : marges élevées et récurrence (cloud, licences). AAPL dépend des cycles iPhone et d’une trésorerie élevée (ROE 151.9%), limitant sa croissance organique. Implications investisseur : - MSFT : Croissance durable, valorisation raisonnable, mais sensibilité à la demande IT. - AAPL : Résilience (marges élevées, trésorerie), mais croissance atone et valorisation premium. Préférer MSFT pour…</a:t>
+              <a:t>AAPL vs MSFT : Analyse comparative Structure : AAPL affiche une croissance modérée (CAGR 1.8%) avec des marges solides (EBITDA 34.8%) mais un levier élevé (ND/EBITDA 0.4). MSFT domine en rentabilité (EBITDA 56.9%, ROIC 30.1%) et croissance (CAGR 12.4%), avec un bilan plus sain (ND/EBITDA 0.1). Pourquoi : MSFT bénéficie d’une diversification (cloud, SaaS) et d’une meilleure scalabilité, tandis qu’AAPL reste dépendant de l’iPhone (marges élevées mais croissance atone). Implications : MSFT offre un meilleur profil risque/rendement (valorisation attractive : PE 27x vs 34x pour AAPL). AAPL, plus défensif, justifie sa prime via sa trésorerie (FCF yield 2.9%). Préférer MSFT pour…</a:t>
             </a:r>
           </a:p>
         </p:txBody>
@@ -34143,7 +34138,7 @@
                 </a:solidFill>
                 <a:latin typeface="Calibri"/>
               </a:rPr>
-              <a:t>AAPL vs MSFT : Analyse comparative Quoi : MSFT affiche des marges (EBITDA 56.9% vs 34.8%) et une croissance (CAGR 12.4% vs 1.8%) supérieures à AAPL, malgré des valorisations plus attractives (PE 27x vs 34.3x, EV/EBITDA 17.3x vs 27x). Pourquoi : Modèle SaaS (MSFT) vs hardware (AAPL) : marges élevées et récurrence (cloud, licences). AAPL dépend des cycles iPhone et d’une trésorerie élevée (ROE 151.9%), limitant sa croissance organique. Implications investisseur : - MSFT : Croissance durable, valorisation raisonnable, mais sensibilité à la demande IT. - AAPL : Résilience (marges élevées, trésorerie), mais croissance</a:t>
+              <a:t>AAPL vs MSFT : Analyse comparative Structure : AAPL affiche une croissance modérée (CAGR 1.8%) avec des marges solides (EBITDA 34.8%) mais un levier élevé (ND/EBITDA 0.4). MSFT domine en rentabilité (EBITDA 56.9%, ROIC 30.1%) et croissance (CAGR 12.4%), avec un bilan plus sain (ND/EBITDA 0.1). Pourquoi : MSFT bénéficie d’une diversification (cloud, SaaS) et d’une meilleure scalabilité, tandis qu’AAPL reste dépendant de l’iPhone (marges élevées mais croissance atone). Implications : MSFT offre un meilleur profil risque/rendement (valorisation attractive : PE 27x vs 34x pour AAPL). AAPL, plus défensif, justifie sa prime via</a:t>
             </a:r>
           </a:p>
         </p:txBody>

</xml_diff>